<commit_message>
Datatable Column Editing Options
</commit_message>
<xml_diff>
--- a/.lessons/34 Packages Yajra Datatable/5 Datatable Column Editing Options/1.pptx
+++ b/.lessons/34 Packages Yajra Datatable/5 Datatable Column Editing Options/1.pptx
@@ -7,7 +7,13 @@
   <p:sldIdLst>
     <p:sldId id="402" r:id="rId2"/>
     <p:sldId id="403" r:id="rId3"/>
-    <p:sldId id="400" r:id="rId4"/>
+    <p:sldId id="404" r:id="rId4"/>
+    <p:sldId id="405" r:id="rId5"/>
+    <p:sldId id="406" r:id="rId6"/>
+    <p:sldId id="407" r:id="rId7"/>
+    <p:sldId id="408" r:id="rId8"/>
+    <p:sldId id="409" r:id="rId9"/>
+    <p:sldId id="400" r:id="rId10"/>
   </p:sldIdLst>
   <p:sldSz cx="12192000" cy="6858000"/>
   <p:notesSz cx="6858000" cy="9144000"/>
@@ -261,7 +267,7 @@
           <a:p>
             <a:fld id="{3E102D2E-813C-461C-9963-687A650C48C0}" type="datetimeFigureOut">
               <a:rPr lang="en-US" smtClean="0"/>
-              <a:t>5/23/2025</a:t>
+              <a:t>6/17/2025</a:t>
             </a:fld>
             <a:endParaRPr lang="en-US"/>
           </a:p>
@@ -459,7 +465,7 @@
           <a:p>
             <a:fld id="{3E102D2E-813C-461C-9963-687A650C48C0}" type="datetimeFigureOut">
               <a:rPr lang="en-US" smtClean="0"/>
-              <a:t>5/23/2025</a:t>
+              <a:t>6/17/2025</a:t>
             </a:fld>
             <a:endParaRPr lang="en-US"/>
           </a:p>
@@ -667,7 +673,7 @@
           <a:p>
             <a:fld id="{3E102D2E-813C-461C-9963-687A650C48C0}" type="datetimeFigureOut">
               <a:rPr lang="en-US" smtClean="0"/>
-              <a:t>5/23/2025</a:t>
+              <a:t>6/17/2025</a:t>
             </a:fld>
             <a:endParaRPr lang="en-US"/>
           </a:p>
@@ -865,7 +871,7 @@
           <a:p>
             <a:fld id="{3E102D2E-813C-461C-9963-687A650C48C0}" type="datetimeFigureOut">
               <a:rPr lang="en-US" smtClean="0"/>
-              <a:t>5/23/2025</a:t>
+              <a:t>6/17/2025</a:t>
             </a:fld>
             <a:endParaRPr lang="en-US"/>
           </a:p>
@@ -1140,7 +1146,7 @@
           <a:p>
             <a:fld id="{3E102D2E-813C-461C-9963-687A650C48C0}" type="datetimeFigureOut">
               <a:rPr lang="en-US" smtClean="0"/>
-              <a:t>5/23/2025</a:t>
+              <a:t>6/17/2025</a:t>
             </a:fld>
             <a:endParaRPr lang="en-US"/>
           </a:p>
@@ -1405,7 +1411,7 @@
           <a:p>
             <a:fld id="{3E102D2E-813C-461C-9963-687A650C48C0}" type="datetimeFigureOut">
               <a:rPr lang="en-US" smtClean="0"/>
-              <a:t>5/23/2025</a:t>
+              <a:t>6/17/2025</a:t>
             </a:fld>
             <a:endParaRPr lang="en-US"/>
           </a:p>
@@ -1817,7 +1823,7 @@
           <a:p>
             <a:fld id="{3E102D2E-813C-461C-9963-687A650C48C0}" type="datetimeFigureOut">
               <a:rPr lang="en-US" smtClean="0"/>
-              <a:t>5/23/2025</a:t>
+              <a:t>6/17/2025</a:t>
             </a:fld>
             <a:endParaRPr lang="en-US"/>
           </a:p>
@@ -1958,7 +1964,7 @@
           <a:p>
             <a:fld id="{3E102D2E-813C-461C-9963-687A650C48C0}" type="datetimeFigureOut">
               <a:rPr lang="en-US" smtClean="0"/>
-              <a:t>5/23/2025</a:t>
+              <a:t>6/17/2025</a:t>
             </a:fld>
             <a:endParaRPr lang="en-US"/>
           </a:p>
@@ -2071,7 +2077,7 @@
           <a:p>
             <a:fld id="{3E102D2E-813C-461C-9963-687A650C48C0}" type="datetimeFigureOut">
               <a:rPr lang="en-US" smtClean="0"/>
-              <a:t>5/23/2025</a:t>
+              <a:t>6/17/2025</a:t>
             </a:fld>
             <a:endParaRPr lang="en-US"/>
           </a:p>
@@ -2382,7 +2388,7 @@
           <a:p>
             <a:fld id="{3E102D2E-813C-461C-9963-687A650C48C0}" type="datetimeFigureOut">
               <a:rPr lang="en-US" smtClean="0"/>
-              <a:t>5/23/2025</a:t>
+              <a:t>6/17/2025</a:t>
             </a:fld>
             <a:endParaRPr lang="en-US"/>
           </a:p>
@@ -2670,7 +2676,7 @@
           <a:p>
             <a:fld id="{3E102D2E-813C-461C-9963-687A650C48C0}" type="datetimeFigureOut">
               <a:rPr lang="en-US" smtClean="0"/>
-              <a:t>5/23/2025</a:t>
+              <a:t>6/17/2025</a:t>
             </a:fld>
             <a:endParaRPr lang="en-US"/>
           </a:p>
@@ -2911,7 +2917,7 @@
           <a:p>
             <a:fld id="{3E102D2E-813C-461C-9963-687A650C48C0}" type="datetimeFigureOut">
               <a:rPr lang="en-US" smtClean="0"/>
-              <a:t>5/23/2025</a:t>
+              <a:t>6/17/2025</a:t>
             </a:fld>
             <a:endParaRPr lang="en-US"/>
           </a:p>
@@ -3349,7 +3355,7 @@
         <p:spPr>
           <a:xfrm>
             <a:off x="217714" y="255046"/>
-            <a:ext cx="11756571" cy="355354"/>
+            <a:ext cx="7899919" cy="655436"/>
           </a:xfrm>
           <a:prstGeom prst="rect">
             <a:avLst/>
@@ -3369,7 +3375,7 @@
               <a:buNone/>
             </a:pPr>
             <a:r>
-              <a:rPr kumimoji="0" lang="en-US" altLang="en-US" sz="1300" b="0" i="0" u="none" strike="noStrike" cap="none" normalizeH="0" baseline="0">
+              <a:rPr kumimoji="0" lang="az-Latn-AZ" altLang="en-US" sz="1300" b="0" i="0" u="none" strike="noStrike" cap="none" normalizeH="0" baseline="0">
                 <a:ln>
                   <a:noFill/>
                 </a:ln>
@@ -3379,11 +3385,185 @@
                 <a:effectLst/>
                 <a:latin typeface="Arial" panose="020B0604020202020204" pitchFamily="34" charset="0"/>
               </a:rPr>
-              <a:t>.</a:t>
-            </a:r>
-          </a:p>
-        </p:txBody>
-      </p:sp>
+              <a:t>Şablona yeni </a:t>
+            </a:r>
+            <a:r>
+              <a:rPr kumimoji="0" lang="az-Latn-AZ" altLang="en-US" sz="1300" b="1" i="0" u="none" strike="noStrike" cap="none" normalizeH="0" baseline="0">
+                <a:ln>
+                  <a:noFill/>
+                </a:ln>
+                <a:solidFill>
+                  <a:schemeClr val="tx1"/>
+                </a:solidFill>
+                <a:effectLst/>
+                <a:latin typeface="Arial" panose="020B0604020202020204" pitchFamily="34" charset="0"/>
+              </a:rPr>
+              <a:t>sütun</a:t>
+            </a:r>
+            <a:r>
+              <a:rPr kumimoji="0" lang="az-Latn-AZ" altLang="en-US" sz="1300" b="0" i="0" u="none" strike="noStrike" cap="none" normalizeH="0" baseline="0">
+                <a:ln>
+                  <a:noFill/>
+                </a:ln>
+                <a:solidFill>
+                  <a:schemeClr val="tx1"/>
+                </a:solidFill>
+                <a:effectLst/>
+                <a:latin typeface="Arial" panose="020B0604020202020204" pitchFamily="34" charset="0"/>
+              </a:rPr>
+              <a:t> əlavə etmək istədikdə </a:t>
+            </a:r>
+            <a:r>
+              <a:rPr kumimoji="0" lang="az-Latn-AZ" altLang="en-US" sz="1300" b="1" i="0" u="none" strike="noStrike" cap="none" normalizeH="0" baseline="0">
+                <a:ln>
+                  <a:noFill/>
+                </a:ln>
+                <a:solidFill>
+                  <a:srgbClr val="FF0000"/>
+                </a:solidFill>
+                <a:effectLst/>
+                <a:latin typeface="Arial" panose="020B0604020202020204" pitchFamily="34" charset="0"/>
+              </a:rPr>
+              <a:t>Column</a:t>
+            </a:r>
+            <a:r>
+              <a:rPr kumimoji="0" lang="az-Latn-AZ" altLang="en-US" sz="1300" b="0" i="0" u="none" strike="noStrike" cap="none" normalizeH="0" baseline="0">
+                <a:ln>
+                  <a:noFill/>
+                </a:ln>
+                <a:solidFill>
+                  <a:schemeClr val="tx1"/>
+                </a:solidFill>
+                <a:effectLst/>
+                <a:latin typeface="Arial" panose="020B0604020202020204" pitchFamily="34" charset="0"/>
+              </a:rPr>
+              <a:t> klasından istifadə edirik. Həmin klasda yazılan ad </a:t>
+            </a:r>
+            <a:r>
+              <a:rPr kumimoji="0" lang="az-Latn-AZ" altLang="en-US" sz="1300" b="1" i="0" u="none" strike="noStrike" cap="none" normalizeH="0" baseline="0">
+                <a:ln>
+                  <a:noFill/>
+                </a:ln>
+                <a:solidFill>
+                  <a:schemeClr val="tx1"/>
+                </a:solidFill>
+                <a:effectLst/>
+                <a:latin typeface="Arial" panose="020B0604020202020204" pitchFamily="34" charset="0"/>
+              </a:rPr>
+              <a:t>DB</a:t>
+            </a:r>
+            <a:r>
+              <a:rPr kumimoji="0" lang="az-Latn-AZ" altLang="en-US" sz="1300" b="0" i="0" u="none" strike="noStrike" cap="none" normalizeH="0" baseline="0">
+                <a:ln>
+                  <a:noFill/>
+                </a:ln>
+                <a:solidFill>
+                  <a:schemeClr val="tx1"/>
+                </a:solidFill>
+                <a:effectLst/>
+                <a:latin typeface="Arial" panose="020B0604020202020204" pitchFamily="34" charset="0"/>
+              </a:rPr>
+              <a:t> -in cədvəlində yazılan </a:t>
+            </a:r>
+            <a:r>
+              <a:rPr kumimoji="0" lang="az-Latn-AZ" altLang="en-US" sz="1300" b="1" i="0" u="none" strike="noStrike" cap="none" normalizeH="0" baseline="0">
+                <a:ln>
+                  <a:noFill/>
+                </a:ln>
+                <a:solidFill>
+                  <a:schemeClr val="tx1"/>
+                </a:solidFill>
+                <a:effectLst/>
+                <a:latin typeface="Arial" panose="020B0604020202020204" pitchFamily="34" charset="0"/>
+              </a:rPr>
+              <a:t>sütun</a:t>
+            </a:r>
+            <a:r>
+              <a:rPr kumimoji="0" lang="az-Latn-AZ" altLang="en-US" sz="1300" b="0" i="0" u="none" strike="noStrike" cap="none" normalizeH="0" baseline="0">
+                <a:ln>
+                  <a:noFill/>
+                </a:ln>
+                <a:solidFill>
+                  <a:schemeClr val="tx1"/>
+                </a:solidFill>
+                <a:effectLst/>
+                <a:latin typeface="Arial" panose="020B0604020202020204" pitchFamily="34" charset="0"/>
+              </a:rPr>
+              <a:t> adı ilə eyni olmalıdır. Əks halda xəta alarıq. </a:t>
+            </a:r>
+            <a:endParaRPr kumimoji="0" lang="en-US" altLang="en-US" sz="1300" b="0" i="0" u="none" strike="noStrike" cap="none" normalizeH="0" baseline="0">
+              <a:ln>
+                <a:noFill/>
+              </a:ln>
+              <a:solidFill>
+                <a:schemeClr val="tx1"/>
+              </a:solidFill>
+              <a:effectLst/>
+              <a:latin typeface="Arial" panose="020B0604020202020204" pitchFamily="34" charset="0"/>
+            </a:endParaRPr>
+          </a:p>
+        </p:txBody>
+      </p:sp>
+      <p:pic>
+        <p:nvPicPr>
+          <p:cNvPr id="4" name="Picture 3">
+            <a:extLst>
+              <a:ext uri="{FF2B5EF4-FFF2-40B4-BE49-F238E27FC236}">
+                <a16:creationId xmlns:a16="http://schemas.microsoft.com/office/drawing/2014/main" id="{2C85B296-D8D7-828E-46AF-7A6B7362C8F9}"/>
+              </a:ext>
+            </a:extLst>
+          </p:cNvPr>
+          <p:cNvPicPr>
+            <a:picLocks noChangeAspect="1"/>
+          </p:cNvPicPr>
+          <p:nvPr/>
+        </p:nvPicPr>
+        <p:blipFill>
+          <a:blip r:embed="rId2"/>
+          <a:stretch>
+            <a:fillRect/>
+          </a:stretch>
+        </p:blipFill>
+        <p:spPr>
+          <a:xfrm>
+            <a:off x="8299841" y="0"/>
+            <a:ext cx="3892159" cy="6858000"/>
+          </a:xfrm>
+          <a:prstGeom prst="rect">
+            <a:avLst/>
+          </a:prstGeom>
+        </p:spPr>
+      </p:pic>
+      <p:pic>
+        <p:nvPicPr>
+          <p:cNvPr id="6" name="Picture 5">
+            <a:extLst>
+              <a:ext uri="{FF2B5EF4-FFF2-40B4-BE49-F238E27FC236}">
+                <a16:creationId xmlns:a16="http://schemas.microsoft.com/office/drawing/2014/main" id="{8254C234-18B4-E899-8FF0-6D6D29405559}"/>
+              </a:ext>
+            </a:extLst>
+          </p:cNvPr>
+          <p:cNvPicPr>
+            <a:picLocks noChangeAspect="1"/>
+          </p:cNvPicPr>
+          <p:nvPr/>
+        </p:nvPicPr>
+        <p:blipFill>
+          <a:blip r:embed="rId3"/>
+          <a:stretch>
+            <a:fillRect/>
+          </a:stretch>
+        </p:blipFill>
+        <p:spPr>
+          <a:xfrm>
+            <a:off x="0" y="1194318"/>
+            <a:ext cx="6989304" cy="2153604"/>
+          </a:xfrm>
+          <a:prstGeom prst="rect">
+            <a:avLst/>
+          </a:prstGeom>
+        </p:spPr>
+      </p:pic>
     </p:spTree>
     <p:extLst>
       <p:ext uri="{BB962C8B-B14F-4D97-AF65-F5344CB8AC3E}">
@@ -3435,7 +3615,7 @@
         <p:spPr>
           <a:xfrm>
             <a:off x="217714" y="255046"/>
-            <a:ext cx="11756571" cy="355354"/>
+            <a:ext cx="11756571" cy="955518"/>
           </a:xfrm>
           <a:prstGeom prst="rect">
             <a:avLst/>
@@ -3455,7 +3635,7 @@
               <a:buNone/>
             </a:pPr>
             <a:r>
-              <a:rPr kumimoji="0" lang="en-US" altLang="en-US" sz="1300" b="0" i="0" u="none" strike="noStrike" cap="none" normalizeH="0" baseline="0">
+              <a:rPr kumimoji="0" lang="az-Latn-AZ" altLang="en-US" sz="1300" b="0" i="0" u="none" strike="noStrike" cap="none" normalizeH="0" baseline="0">
                 <a:ln>
                   <a:noFill/>
                 </a:ln>
@@ -3465,11 +3645,118 @@
                 <a:effectLst/>
                 <a:latin typeface="Arial" panose="020B0604020202020204" pitchFamily="34" charset="0"/>
               </a:rPr>
-              <a:t>.</a:t>
-            </a:r>
-          </a:p>
-        </p:txBody>
-      </p:sp>
+              <a:t>Sütun adını doğru yazdıqda nəticə aşağı şəkildəki kimi olacaq.</a:t>
+            </a:r>
+          </a:p>
+          <a:p>
+            <a:pPr>
+              <a:lnSpc>
+                <a:spcPct val="150000"/>
+              </a:lnSpc>
+              <a:buNone/>
+            </a:pPr>
+            <a:endParaRPr lang="az-Latn-AZ" altLang="en-US" sz="1300">
+              <a:latin typeface="Arial" panose="020B0604020202020204" pitchFamily="34" charset="0"/>
+            </a:endParaRPr>
+          </a:p>
+          <a:p>
+            <a:pPr>
+              <a:lnSpc>
+                <a:spcPct val="150000"/>
+              </a:lnSpc>
+              <a:buNone/>
+            </a:pPr>
+            <a:r>
+              <a:rPr lang="az-Latn-AZ" altLang="en-US" sz="1300">
+                <a:latin typeface="Arial" panose="020B0604020202020204" pitchFamily="34" charset="0"/>
+              </a:rPr>
+              <a:t>Bunu gördükdən sonra `</a:t>
+            </a:r>
+            <a:r>
+              <a:rPr lang="az-Latn-AZ" altLang="en-US" sz="1300" b="1">
+                <a:latin typeface="Arial" panose="020B0604020202020204" pitchFamily="34" charset="0"/>
+              </a:rPr>
+              <a:t>email_verified_at</a:t>
+            </a:r>
+            <a:r>
+              <a:rPr lang="az-Latn-AZ" altLang="en-US" sz="1300">
+                <a:latin typeface="Arial" panose="020B0604020202020204" pitchFamily="34" charset="0"/>
+              </a:rPr>
+              <a:t>` sütununu commentə alın...</a:t>
+            </a:r>
+            <a:endParaRPr kumimoji="0" lang="az-Latn-AZ" altLang="en-US" sz="1300" b="0" i="0" u="none" strike="noStrike" cap="none" normalizeH="0" baseline="0">
+              <a:ln>
+                <a:noFill/>
+              </a:ln>
+              <a:solidFill>
+                <a:schemeClr val="tx1"/>
+              </a:solidFill>
+              <a:effectLst/>
+              <a:latin typeface="Arial" panose="020B0604020202020204" pitchFamily="34" charset="0"/>
+            </a:endParaRPr>
+          </a:p>
+        </p:txBody>
+      </p:sp>
+      <p:pic>
+        <p:nvPicPr>
+          <p:cNvPr id="4" name="Picture 3">
+            <a:extLst>
+              <a:ext uri="{FF2B5EF4-FFF2-40B4-BE49-F238E27FC236}">
+                <a16:creationId xmlns:a16="http://schemas.microsoft.com/office/drawing/2014/main" id="{33DB0C91-67E0-3754-7711-A234C61C66BB}"/>
+              </a:ext>
+            </a:extLst>
+          </p:cNvPr>
+          <p:cNvPicPr>
+            <a:picLocks noChangeAspect="1"/>
+          </p:cNvPicPr>
+          <p:nvPr/>
+        </p:nvPicPr>
+        <p:blipFill>
+          <a:blip r:embed="rId2"/>
+          <a:stretch>
+            <a:fillRect/>
+          </a:stretch>
+        </p:blipFill>
+        <p:spPr>
+          <a:xfrm>
+            <a:off x="0" y="4122824"/>
+            <a:ext cx="7667145" cy="2735176"/>
+          </a:xfrm>
+          <a:prstGeom prst="rect">
+            <a:avLst/>
+          </a:prstGeom>
+        </p:spPr>
+      </p:pic>
+      <p:pic>
+        <p:nvPicPr>
+          <p:cNvPr id="6" name="Picture 5">
+            <a:extLst>
+              <a:ext uri="{FF2B5EF4-FFF2-40B4-BE49-F238E27FC236}">
+                <a16:creationId xmlns:a16="http://schemas.microsoft.com/office/drawing/2014/main" id="{506F3F31-9A4B-72BF-A6B0-0A685990AABE}"/>
+              </a:ext>
+            </a:extLst>
+          </p:cNvPr>
+          <p:cNvPicPr>
+            <a:picLocks noChangeAspect="1"/>
+          </p:cNvPicPr>
+          <p:nvPr/>
+        </p:nvPicPr>
+        <p:blipFill>
+          <a:blip r:embed="rId3"/>
+          <a:stretch>
+            <a:fillRect/>
+          </a:stretch>
+        </p:blipFill>
+        <p:spPr>
+          <a:xfrm>
+            <a:off x="8408831" y="0"/>
+            <a:ext cx="3783169" cy="6858000"/>
+          </a:xfrm>
+          <a:prstGeom prst="rect">
+            <a:avLst/>
+          </a:prstGeom>
+        </p:spPr>
+      </p:pic>
     </p:spTree>
     <p:extLst>
       <p:ext uri="{BB962C8B-B14F-4D97-AF65-F5344CB8AC3E}">
@@ -3484,6 +3771,1673 @@
 </file>
 
 <file path=ppt/slides/slide3.xml><?xml version="1.0" encoding="utf-8"?>
+<p:sld xmlns:a="http://schemas.openxmlformats.org/drawingml/2006/main" xmlns:r="http://schemas.openxmlformats.org/officeDocument/2006/relationships" xmlns:p="http://schemas.openxmlformats.org/presentationml/2006/main">
+  <p:cSld>
+    <p:spTree>
+      <p:nvGrpSpPr>
+        <p:cNvPr id="1" name="">
+          <a:extLst>
+            <a:ext uri="{FF2B5EF4-FFF2-40B4-BE49-F238E27FC236}">
+              <a16:creationId xmlns:a16="http://schemas.microsoft.com/office/drawing/2014/main" id="{2B449072-3188-9CAC-16D5-7EE91C3C309B}"/>
+            </a:ext>
+          </a:extLst>
+        </p:cNvPr>
+        <p:cNvGrpSpPr/>
+        <p:nvPr/>
+      </p:nvGrpSpPr>
+      <p:grpSpPr>
+        <a:xfrm>
+          <a:off x="0" y="0"/>
+          <a:ext cx="0" cy="0"/>
+          <a:chOff x="0" y="0"/>
+          <a:chExt cx="0" cy="0"/>
+        </a:xfrm>
+      </p:grpSpPr>
+      <p:sp>
+        <p:nvSpPr>
+          <p:cNvPr id="3" name="TextBox 2">
+            <a:extLst>
+              <a:ext uri="{FF2B5EF4-FFF2-40B4-BE49-F238E27FC236}">
+                <a16:creationId xmlns:a16="http://schemas.microsoft.com/office/drawing/2014/main" id="{D97DB176-6D67-4C28-0A8E-EDFD4BFD510B}"/>
+              </a:ext>
+            </a:extLst>
+          </p:cNvPr>
+          <p:cNvSpPr txBox="1"/>
+          <p:nvPr/>
+        </p:nvSpPr>
+        <p:spPr>
+          <a:xfrm>
+            <a:off x="158620" y="255046"/>
+            <a:ext cx="7445829" cy="4490140"/>
+          </a:xfrm>
+          <a:prstGeom prst="rect">
+            <a:avLst/>
+          </a:prstGeom>
+          <a:noFill/>
+        </p:spPr>
+        <p:txBody>
+          <a:bodyPr wrap="square">
+            <a:spAutoFit/>
+          </a:bodyPr>
+          <a:lstStyle/>
+          <a:p>
+            <a:pPr>
+              <a:lnSpc>
+                <a:spcPct val="150000"/>
+              </a:lnSpc>
+              <a:buNone/>
+            </a:pPr>
+            <a:r>
+              <a:rPr lang="az-Latn-AZ" altLang="en-US" sz="1200" b="1">
+                <a:latin typeface="Arial" panose="020B0604020202020204" pitchFamily="34" charset="0"/>
+              </a:rPr>
+              <a:t>DB</a:t>
+            </a:r>
+            <a:r>
+              <a:rPr lang="az-Latn-AZ" altLang="en-US" sz="1200">
+                <a:latin typeface="Arial" panose="020B0604020202020204" pitchFamily="34" charset="0"/>
+              </a:rPr>
+              <a:t> -in </a:t>
+            </a:r>
+            <a:r>
+              <a:rPr lang="az-Latn-AZ" altLang="en-US" sz="1200" b="1">
+                <a:latin typeface="Arial" panose="020B0604020202020204" pitchFamily="34" charset="0"/>
+              </a:rPr>
+              <a:t>cədvəlində</a:t>
+            </a:r>
+            <a:r>
+              <a:rPr lang="az-Latn-AZ" altLang="en-US" sz="1200">
+                <a:latin typeface="Arial" panose="020B0604020202020204" pitchFamily="34" charset="0"/>
+              </a:rPr>
+              <a:t> olmayan </a:t>
+            </a:r>
+            <a:r>
+              <a:rPr lang="az-Latn-AZ" altLang="en-US" sz="1200" b="1">
+                <a:latin typeface="Arial" panose="020B0604020202020204" pitchFamily="34" charset="0"/>
+              </a:rPr>
+              <a:t>sütunu</a:t>
+            </a:r>
+            <a:r>
+              <a:rPr lang="az-Latn-AZ" altLang="en-US" sz="1200">
+                <a:latin typeface="Arial" panose="020B0604020202020204" pitchFamily="34" charset="0"/>
+              </a:rPr>
+              <a:t> əlavə etdiyimiz zaman xəta alırıq dedik. </a:t>
+            </a:r>
+          </a:p>
+          <a:p>
+            <a:pPr>
+              <a:lnSpc>
+                <a:spcPct val="150000"/>
+              </a:lnSpc>
+              <a:buNone/>
+            </a:pPr>
+            <a:endParaRPr kumimoji="0" lang="az-Latn-AZ" altLang="en-US" sz="1200" b="0" i="0" u="none" strike="noStrike" cap="none" normalizeH="0" baseline="0">
+              <a:ln>
+                <a:noFill/>
+              </a:ln>
+              <a:solidFill>
+                <a:schemeClr val="tx1"/>
+              </a:solidFill>
+              <a:effectLst/>
+              <a:latin typeface="Arial" panose="020B0604020202020204" pitchFamily="34" charset="0"/>
+            </a:endParaRPr>
+          </a:p>
+          <a:p>
+            <a:pPr>
+              <a:lnSpc>
+                <a:spcPct val="150000"/>
+              </a:lnSpc>
+              <a:buNone/>
+            </a:pPr>
+            <a:r>
+              <a:rPr lang="az-Latn-AZ" altLang="en-US" sz="1200" b="1">
+                <a:latin typeface="Arial" panose="020B0604020202020204" pitchFamily="34" charset="0"/>
+              </a:rPr>
+              <a:t>Xəta almamaq üçün</a:t>
+            </a:r>
+            <a:r>
+              <a:rPr lang="az-Latn-AZ" altLang="en-US" sz="1200">
+                <a:latin typeface="Arial" panose="020B0604020202020204" pitchFamily="34" charset="0"/>
+              </a:rPr>
+              <a:t>:</a:t>
+            </a:r>
+          </a:p>
+          <a:p>
+            <a:pPr marL="742950" lvl="1" indent="-285750">
+              <a:lnSpc>
+                <a:spcPct val="150000"/>
+              </a:lnSpc>
+              <a:buFont typeface="Arial" panose="020B0604020202020204" pitchFamily="34" charset="0"/>
+              <a:buChar char="•"/>
+            </a:pPr>
+            <a:r>
+              <a:rPr lang="az-Latn-AZ" altLang="en-US" sz="1200" b="1">
+                <a:latin typeface="Arial" panose="020B0604020202020204" pitchFamily="34" charset="0"/>
+              </a:rPr>
+              <a:t>Column() </a:t>
+            </a:r>
+            <a:r>
+              <a:rPr lang="az-Latn-AZ" altLang="en-US" sz="1200">
+                <a:latin typeface="Arial" panose="020B0604020202020204" pitchFamily="34" charset="0"/>
+              </a:rPr>
+              <a:t>klası ilə şablonda hansı sütunun görünməsi gərəkdiyini bildiririk.</a:t>
+            </a:r>
+          </a:p>
+          <a:p>
+            <a:pPr marL="742950" lvl="1" indent="-285750">
+              <a:lnSpc>
+                <a:spcPct val="150000"/>
+              </a:lnSpc>
+              <a:buFont typeface="Arial" panose="020B0604020202020204" pitchFamily="34" charset="0"/>
+              <a:buChar char="•"/>
+            </a:pPr>
+            <a:r>
+              <a:rPr lang="az-Latn-AZ" altLang="en-US" sz="1200" b="1">
+                <a:solidFill>
+                  <a:srgbClr val="00B050"/>
+                </a:solidFill>
+                <a:latin typeface="Arial" panose="020B0604020202020204" pitchFamily="34" charset="0"/>
+              </a:rPr>
+              <a:t>dataTable()</a:t>
+            </a:r>
+            <a:r>
+              <a:rPr lang="az-Latn-AZ" altLang="en-US" sz="1200">
+                <a:solidFill>
+                  <a:srgbClr val="00B050"/>
+                </a:solidFill>
+                <a:latin typeface="Arial" panose="020B0604020202020204" pitchFamily="34" charset="0"/>
+              </a:rPr>
+              <a:t> </a:t>
+            </a:r>
+            <a:r>
+              <a:rPr lang="az-Latn-AZ" altLang="en-US" sz="1200">
+                <a:latin typeface="Arial" panose="020B0604020202020204" pitchFamily="34" charset="0"/>
+              </a:rPr>
+              <a:t>funksiyası içindəki, </a:t>
+            </a:r>
+            <a:r>
+              <a:rPr lang="az-Latn-AZ" altLang="en-US" sz="1200" b="1">
+                <a:solidFill>
+                  <a:srgbClr val="FF0000"/>
+                </a:solidFill>
+                <a:latin typeface="Arial" panose="020B0604020202020204" pitchFamily="34" charset="0"/>
+              </a:rPr>
+              <a:t>addColumn() </a:t>
+            </a:r>
+            <a:r>
+              <a:rPr lang="az-Latn-AZ" altLang="en-US" sz="1200">
+                <a:latin typeface="Arial" panose="020B0604020202020204" pitchFamily="34" charset="0"/>
+              </a:rPr>
+              <a:t>metodu ilə isə bu </a:t>
+            </a:r>
+            <a:r>
+              <a:rPr lang="az-Latn-AZ" altLang="en-US" sz="1200" b="1">
+                <a:latin typeface="Arial" panose="020B0604020202020204" pitchFamily="34" charset="0"/>
+              </a:rPr>
+              <a:t>sütunu</a:t>
+            </a:r>
+            <a:r>
+              <a:rPr lang="az-Latn-AZ" altLang="en-US" sz="1200">
+                <a:latin typeface="Arial" panose="020B0604020202020204" pitchFamily="34" charset="0"/>
+              </a:rPr>
+              <a:t> və </a:t>
+            </a:r>
+            <a:r>
+              <a:rPr lang="az-Latn-AZ" altLang="en-US" sz="1200" b="1">
+                <a:latin typeface="Arial" panose="020B0604020202020204" pitchFamily="34" charset="0"/>
+              </a:rPr>
+              <a:t>dəyərini</a:t>
+            </a:r>
+            <a:r>
+              <a:rPr lang="az-Latn-AZ" altLang="en-US" sz="1200">
+                <a:latin typeface="Arial" panose="020B0604020202020204" pitchFamily="34" charset="0"/>
+              </a:rPr>
+              <a:t> yaradırıq.</a:t>
+            </a:r>
+          </a:p>
+          <a:p>
+            <a:pPr>
+              <a:lnSpc>
+                <a:spcPct val="150000"/>
+              </a:lnSpc>
+              <a:buNone/>
+            </a:pPr>
+            <a:endParaRPr kumimoji="0" lang="az-Latn-AZ" altLang="en-US" sz="1200" b="0" i="0" u="none" strike="noStrike" cap="none" normalizeH="0" baseline="0">
+              <a:ln>
+                <a:noFill/>
+              </a:ln>
+              <a:solidFill>
+                <a:schemeClr val="tx1"/>
+              </a:solidFill>
+              <a:effectLst/>
+              <a:latin typeface="Arial" panose="020B0604020202020204" pitchFamily="34" charset="0"/>
+            </a:endParaRPr>
+          </a:p>
+          <a:p>
+            <a:pPr>
+              <a:lnSpc>
+                <a:spcPct val="150000"/>
+              </a:lnSpc>
+              <a:buNone/>
+            </a:pPr>
+            <a:endParaRPr kumimoji="0" lang="en-US" altLang="en-US" sz="1200" b="0" i="0" u="none" strike="noStrike" cap="none" normalizeH="0" baseline="0">
+              <a:ln>
+                <a:noFill/>
+              </a:ln>
+              <a:solidFill>
+                <a:schemeClr val="tx1"/>
+              </a:solidFill>
+              <a:effectLst/>
+              <a:latin typeface="Arial" panose="020B0604020202020204" pitchFamily="34" charset="0"/>
+            </a:endParaRPr>
+          </a:p>
+          <a:p>
+            <a:pPr>
+              <a:lnSpc>
+                <a:spcPct val="150000"/>
+              </a:lnSpc>
+              <a:buNone/>
+            </a:pPr>
+            <a:endParaRPr lang="en-US" altLang="en-US" sz="1200">
+              <a:latin typeface="Arial" panose="020B0604020202020204" pitchFamily="34" charset="0"/>
+            </a:endParaRPr>
+          </a:p>
+          <a:p>
+            <a:pPr>
+              <a:lnSpc>
+                <a:spcPct val="150000"/>
+              </a:lnSpc>
+              <a:buNone/>
+            </a:pPr>
+            <a:endParaRPr kumimoji="0" lang="en-US" altLang="en-US" sz="1200" b="0" i="0" u="none" strike="noStrike" cap="none" normalizeH="0" baseline="0">
+              <a:ln>
+                <a:noFill/>
+              </a:ln>
+              <a:solidFill>
+                <a:schemeClr val="tx1"/>
+              </a:solidFill>
+              <a:effectLst/>
+              <a:latin typeface="Arial" panose="020B0604020202020204" pitchFamily="34" charset="0"/>
+            </a:endParaRPr>
+          </a:p>
+          <a:p>
+            <a:pPr>
+              <a:lnSpc>
+                <a:spcPct val="150000"/>
+              </a:lnSpc>
+              <a:buNone/>
+            </a:pPr>
+            <a:endParaRPr lang="en-US" altLang="en-US" sz="1200">
+              <a:latin typeface="Arial" panose="020B0604020202020204" pitchFamily="34" charset="0"/>
+            </a:endParaRPr>
+          </a:p>
+          <a:p>
+            <a:pPr>
+              <a:lnSpc>
+                <a:spcPct val="150000"/>
+              </a:lnSpc>
+              <a:buNone/>
+            </a:pPr>
+            <a:endParaRPr kumimoji="0" lang="en-US" altLang="en-US" sz="1200" b="0" i="0" u="none" strike="noStrike" cap="none" normalizeH="0" baseline="0">
+              <a:ln>
+                <a:noFill/>
+              </a:ln>
+              <a:solidFill>
+                <a:schemeClr val="tx1"/>
+              </a:solidFill>
+              <a:effectLst/>
+              <a:latin typeface="Arial" panose="020B0604020202020204" pitchFamily="34" charset="0"/>
+            </a:endParaRPr>
+          </a:p>
+          <a:p>
+            <a:pPr>
+              <a:lnSpc>
+                <a:spcPct val="150000"/>
+              </a:lnSpc>
+              <a:buNone/>
+            </a:pPr>
+            <a:endParaRPr lang="en-US" altLang="en-US" sz="1200">
+              <a:latin typeface="Arial" panose="020B0604020202020204" pitchFamily="34" charset="0"/>
+            </a:endParaRPr>
+          </a:p>
+          <a:p>
+            <a:pPr>
+              <a:lnSpc>
+                <a:spcPct val="150000"/>
+              </a:lnSpc>
+              <a:buNone/>
+            </a:pPr>
+            <a:endParaRPr kumimoji="0" lang="en-US" altLang="en-US" sz="1200" b="0" i="0" u="none" strike="noStrike" cap="none" normalizeH="0" baseline="0">
+              <a:ln>
+                <a:noFill/>
+              </a:ln>
+              <a:solidFill>
+                <a:schemeClr val="tx1"/>
+              </a:solidFill>
+              <a:effectLst/>
+              <a:latin typeface="Arial" panose="020B0604020202020204" pitchFamily="34" charset="0"/>
+            </a:endParaRPr>
+          </a:p>
+          <a:p>
+            <a:pPr>
+              <a:lnSpc>
+                <a:spcPct val="150000"/>
+              </a:lnSpc>
+              <a:buNone/>
+            </a:pPr>
+            <a:endParaRPr lang="en-US" altLang="en-US" sz="1200">
+              <a:latin typeface="Arial" panose="020B0604020202020204" pitchFamily="34" charset="0"/>
+            </a:endParaRPr>
+          </a:p>
+          <a:p>
+            <a:pPr>
+              <a:lnSpc>
+                <a:spcPct val="150000"/>
+              </a:lnSpc>
+              <a:buNone/>
+            </a:pPr>
+            <a:r>
+              <a:rPr kumimoji="0" lang="en-US" altLang="en-US" sz="1200" b="0" i="0" u="none" strike="noStrike" cap="none" normalizeH="0" baseline="0">
+                <a:ln>
+                  <a:noFill/>
+                </a:ln>
+                <a:solidFill>
+                  <a:schemeClr val="tx1"/>
+                </a:solidFill>
+                <a:effectLst/>
+                <a:latin typeface="Arial" panose="020B0604020202020204" pitchFamily="34" charset="0"/>
+              </a:rPr>
+              <a:t>Ancaq h</a:t>
+            </a:r>
+            <a:r>
+              <a:rPr kumimoji="0" lang="az-Latn-AZ" altLang="en-US" sz="1200" b="0" i="0" u="none" strike="noStrike" cap="none" normalizeH="0" baseline="0">
+                <a:ln>
+                  <a:noFill/>
+                </a:ln>
+                <a:solidFill>
+                  <a:schemeClr val="tx1"/>
+                </a:solidFill>
+                <a:effectLst/>
+                <a:latin typeface="Arial" panose="020B0604020202020204" pitchFamily="34" charset="0"/>
+              </a:rPr>
+              <a:t>əmin sütuna </a:t>
+            </a:r>
+            <a:r>
+              <a:rPr lang="en-US" altLang="en-US" sz="1200" b="1">
+                <a:latin typeface="Arial" panose="020B0604020202020204" pitchFamily="34" charset="0"/>
+              </a:rPr>
+              <a:t>&lt;a&gt;</a:t>
+            </a:r>
+            <a:r>
+              <a:rPr lang="en-US" altLang="en-US" sz="1200">
+                <a:latin typeface="Arial" panose="020B0604020202020204" pitchFamily="34" charset="0"/>
+              </a:rPr>
+              <a:t> </a:t>
+            </a:r>
+            <a:r>
+              <a:rPr lang="az-Latn-AZ" altLang="en-US" sz="1200">
+                <a:latin typeface="Arial" panose="020B0604020202020204" pitchFamily="34" charset="0"/>
+              </a:rPr>
+              <a:t>tag -i ilə </a:t>
+            </a:r>
+            <a:r>
+              <a:rPr kumimoji="0" lang="az-Latn-AZ" altLang="en-US" sz="1200" b="1" i="0" u="none" strike="noStrike" cap="none" normalizeH="0" baseline="0">
+                <a:ln>
+                  <a:noFill/>
+                </a:ln>
+                <a:solidFill>
+                  <a:schemeClr val="tx1"/>
+                </a:solidFill>
+                <a:effectLst/>
+                <a:latin typeface="Arial" panose="020B0604020202020204" pitchFamily="34" charset="0"/>
+              </a:rPr>
+              <a:t>EDİT</a:t>
+            </a:r>
+            <a:r>
+              <a:rPr kumimoji="0" lang="az-Latn-AZ" altLang="en-US" sz="1200" b="0" i="0" u="none" strike="noStrike" cap="none" normalizeH="0" baseline="0">
+                <a:ln>
+                  <a:noFill/>
+                </a:ln>
+                <a:solidFill>
+                  <a:schemeClr val="tx1"/>
+                </a:solidFill>
+                <a:effectLst/>
+                <a:latin typeface="Arial" panose="020B0604020202020204" pitchFamily="34" charset="0"/>
+              </a:rPr>
+              <a:t> adlı düymədə əlavə edə bilərik. Bunun üçün </a:t>
+            </a:r>
+            <a:r>
+              <a:rPr lang="az-Latn-AZ" altLang="en-US" sz="1200" b="1">
+                <a:solidFill>
+                  <a:srgbClr val="FF0000"/>
+                </a:solidFill>
+                <a:latin typeface="Arial" panose="020B0604020202020204" pitchFamily="34" charset="0"/>
+              </a:rPr>
+              <a:t>addColumn() </a:t>
+            </a:r>
+            <a:r>
+              <a:rPr lang="az-Latn-AZ" altLang="en-US" sz="1200">
+                <a:latin typeface="Arial" panose="020B0604020202020204" pitchFamily="34" charset="0"/>
+              </a:rPr>
+              <a:t>metodunun 2ci parametrində </a:t>
+            </a:r>
+            <a:r>
+              <a:rPr lang="az-Latn-AZ" altLang="en-US" sz="1200" b="1">
+                <a:solidFill>
+                  <a:srgbClr val="0070C0"/>
+                </a:solidFill>
+                <a:latin typeface="Arial" panose="020B0604020202020204" pitchFamily="34" charset="0"/>
+              </a:rPr>
+              <a:t>callback</a:t>
+            </a:r>
+            <a:r>
+              <a:rPr lang="az-Latn-AZ" altLang="en-US" sz="1200">
+                <a:latin typeface="Arial" panose="020B0604020202020204" pitchFamily="34" charset="0"/>
+              </a:rPr>
+              <a:t> yazmaq lazımdır.</a:t>
+            </a:r>
+            <a:r>
+              <a:rPr lang="en-US" altLang="en-US" sz="1200">
+                <a:latin typeface="Arial" panose="020B0604020202020204" pitchFamily="34" charset="0"/>
+              </a:rPr>
+              <a:t> </a:t>
+            </a:r>
+            <a:r>
+              <a:rPr lang="az-Latn-AZ" altLang="en-US" sz="1200">
+                <a:latin typeface="Arial" panose="020B0604020202020204" pitchFamily="34" charset="0"/>
+              </a:rPr>
+              <a:t>Ardı növbəti slaydda....</a:t>
+            </a:r>
+            <a:endParaRPr lang="en-US" altLang="en-US" sz="1200">
+              <a:latin typeface="Arial" panose="020B0604020202020204" pitchFamily="34" charset="0"/>
+            </a:endParaRPr>
+          </a:p>
+        </p:txBody>
+      </p:sp>
+      <p:pic>
+        <p:nvPicPr>
+          <p:cNvPr id="4" name="Picture 3">
+            <a:extLst>
+              <a:ext uri="{FF2B5EF4-FFF2-40B4-BE49-F238E27FC236}">
+                <a16:creationId xmlns:a16="http://schemas.microsoft.com/office/drawing/2014/main" id="{7E64E04C-7F19-42B9-8CEC-4A9AD382729D}"/>
+              </a:ext>
+            </a:extLst>
+          </p:cNvPr>
+          <p:cNvPicPr>
+            <a:picLocks noChangeAspect="1"/>
+          </p:cNvPicPr>
+          <p:nvPr/>
+        </p:nvPicPr>
+        <p:blipFill>
+          <a:blip r:embed="rId2"/>
+          <a:stretch>
+            <a:fillRect/>
+          </a:stretch>
+        </p:blipFill>
+        <p:spPr>
+          <a:xfrm>
+            <a:off x="7720013" y="0"/>
+            <a:ext cx="4471987" cy="6858000"/>
+          </a:xfrm>
+          <a:prstGeom prst="rect">
+            <a:avLst/>
+          </a:prstGeom>
+        </p:spPr>
+      </p:pic>
+      <p:pic>
+        <p:nvPicPr>
+          <p:cNvPr id="6" name="Picture 5">
+            <a:extLst>
+              <a:ext uri="{FF2B5EF4-FFF2-40B4-BE49-F238E27FC236}">
+                <a16:creationId xmlns:a16="http://schemas.microsoft.com/office/drawing/2014/main" id="{790C3CB7-6410-457D-FF4F-0246E5E304AB}"/>
+              </a:ext>
+            </a:extLst>
+          </p:cNvPr>
+          <p:cNvPicPr>
+            <a:picLocks noChangeAspect="1"/>
+          </p:cNvPicPr>
+          <p:nvPr/>
+        </p:nvPicPr>
+        <p:blipFill>
+          <a:blip r:embed="rId3"/>
+          <a:stretch>
+            <a:fillRect/>
+          </a:stretch>
+        </p:blipFill>
+        <p:spPr>
+          <a:xfrm>
+            <a:off x="158620" y="2252196"/>
+            <a:ext cx="5937380" cy="1152889"/>
+          </a:xfrm>
+          <a:prstGeom prst="rect">
+            <a:avLst/>
+          </a:prstGeom>
+          <a:ln w="38100" cap="sq">
+            <a:solidFill>
+              <a:srgbClr val="000000"/>
+            </a:solidFill>
+            <a:prstDash val="solid"/>
+            <a:miter lim="800000"/>
+          </a:ln>
+          <a:effectLst>
+            <a:outerShdw blurRad="50800" dist="38100" dir="2700000" algn="tl" rotWithShape="0">
+              <a:srgbClr val="000000">
+                <a:alpha val="43000"/>
+              </a:srgbClr>
+            </a:outerShdw>
+          </a:effectLst>
+        </p:spPr>
+      </p:pic>
+    </p:spTree>
+    <p:extLst>
+      <p:ext uri="{BB962C8B-B14F-4D97-AF65-F5344CB8AC3E}">
+        <p14:creationId xmlns:p14="http://schemas.microsoft.com/office/powerpoint/2010/main" val="1270860298"/>
+      </p:ext>
+    </p:extLst>
+  </p:cSld>
+  <p:clrMapOvr>
+    <a:masterClrMapping/>
+  </p:clrMapOvr>
+</p:sld>
+</file>
+
+<file path=ppt/slides/slide4.xml><?xml version="1.0" encoding="utf-8"?>
+<p:sld xmlns:a="http://schemas.openxmlformats.org/drawingml/2006/main" xmlns:r="http://schemas.openxmlformats.org/officeDocument/2006/relationships" xmlns:p="http://schemas.openxmlformats.org/presentationml/2006/main">
+  <p:cSld>
+    <p:spTree>
+      <p:nvGrpSpPr>
+        <p:cNvPr id="1" name="">
+          <a:extLst>
+            <a:ext uri="{FF2B5EF4-FFF2-40B4-BE49-F238E27FC236}">
+              <a16:creationId xmlns:a16="http://schemas.microsoft.com/office/drawing/2014/main" id="{A7D02E50-6451-2967-9460-D72F8CFDE42D}"/>
+            </a:ext>
+          </a:extLst>
+        </p:cNvPr>
+        <p:cNvGrpSpPr/>
+        <p:nvPr/>
+      </p:nvGrpSpPr>
+      <p:grpSpPr>
+        <a:xfrm>
+          <a:off x="0" y="0"/>
+          <a:ext cx="0" cy="0"/>
+          <a:chOff x="0" y="0"/>
+          <a:chExt cx="0" cy="0"/>
+        </a:xfrm>
+      </p:grpSpPr>
+      <p:sp>
+        <p:nvSpPr>
+          <p:cNvPr id="3" name="TextBox 2">
+            <a:extLst>
+              <a:ext uri="{FF2B5EF4-FFF2-40B4-BE49-F238E27FC236}">
+                <a16:creationId xmlns:a16="http://schemas.microsoft.com/office/drawing/2014/main" id="{41FDDF32-87A0-BF68-D1AB-3D8B91CA7E9F}"/>
+              </a:ext>
+            </a:extLst>
+          </p:cNvPr>
+          <p:cNvSpPr txBox="1"/>
+          <p:nvPr/>
+        </p:nvSpPr>
+        <p:spPr>
+          <a:xfrm>
+            <a:off x="217714" y="255046"/>
+            <a:ext cx="11756571" cy="3056093"/>
+          </a:xfrm>
+          <a:prstGeom prst="rect">
+            <a:avLst/>
+          </a:prstGeom>
+          <a:noFill/>
+        </p:spPr>
+        <p:txBody>
+          <a:bodyPr wrap="square">
+            <a:spAutoFit/>
+          </a:bodyPr>
+          <a:lstStyle/>
+          <a:p>
+            <a:pPr>
+              <a:lnSpc>
+                <a:spcPct val="150000"/>
+              </a:lnSpc>
+              <a:buNone/>
+            </a:pPr>
+            <a:r>
+              <a:rPr lang="az-Latn-AZ" altLang="en-US" sz="1300" b="1">
+                <a:latin typeface="Arial" panose="020B0604020202020204" pitchFamily="34" charset="0"/>
+              </a:rPr>
+              <a:t>Callback</a:t>
+            </a:r>
+            <a:r>
+              <a:rPr lang="az-Latn-AZ" altLang="en-US" sz="1300">
+                <a:latin typeface="Arial" panose="020B0604020202020204" pitchFamily="34" charset="0"/>
+              </a:rPr>
+              <a:t> -in </a:t>
+            </a:r>
+            <a:r>
+              <a:rPr lang="en-US" altLang="en-US" sz="1300" b="1">
+                <a:latin typeface="Arial" panose="020B0604020202020204" pitchFamily="34" charset="0"/>
+              </a:rPr>
+              <a:t>&lt;a&gt;</a:t>
+            </a:r>
+            <a:r>
+              <a:rPr lang="en-US" altLang="en-US" sz="1300">
+                <a:latin typeface="Arial" panose="020B0604020202020204" pitchFamily="34" charset="0"/>
+              </a:rPr>
+              <a:t> </a:t>
+            </a:r>
+            <a:r>
+              <a:rPr lang="az-Latn-AZ" altLang="en-US" sz="1300">
+                <a:latin typeface="Arial" panose="020B0604020202020204" pitchFamily="34" charset="0"/>
+              </a:rPr>
+              <a:t>-taginin </a:t>
+            </a:r>
+            <a:r>
+              <a:rPr lang="az-Latn-AZ" altLang="en-US" sz="1300" b="1">
+                <a:latin typeface="Arial" panose="020B0604020202020204" pitchFamily="34" charset="0"/>
+              </a:rPr>
+              <a:t>href</a:t>
+            </a:r>
+            <a:r>
+              <a:rPr lang="az-Latn-AZ" altLang="en-US" sz="1300">
+                <a:latin typeface="Arial" panose="020B0604020202020204" pitchFamily="34" charset="0"/>
+              </a:rPr>
+              <a:t> atributuna, </a:t>
+            </a:r>
+            <a:r>
+              <a:rPr lang="az-Latn-AZ" altLang="en-US" sz="1300" b="1">
+                <a:latin typeface="Arial" panose="020B0604020202020204" pitchFamily="34" charset="0"/>
+              </a:rPr>
+              <a:t>route('user.edit', $query-&gt;id) </a:t>
+            </a:r>
+            <a:r>
+              <a:rPr lang="az-Latn-AZ" altLang="en-US" sz="1300">
+                <a:latin typeface="Arial" panose="020B0604020202020204" pitchFamily="34" charset="0"/>
+              </a:rPr>
+              <a:t>əlavə edirik.  </a:t>
+            </a:r>
+          </a:p>
+          <a:p>
+            <a:pPr>
+              <a:lnSpc>
+                <a:spcPct val="150000"/>
+              </a:lnSpc>
+              <a:buNone/>
+            </a:pPr>
+            <a:endParaRPr kumimoji="0" lang="az-Latn-AZ" altLang="en-US" sz="1300" b="0" i="0" u="none" strike="noStrike" cap="none" normalizeH="0" baseline="0">
+              <a:ln>
+                <a:noFill/>
+              </a:ln>
+              <a:solidFill>
+                <a:schemeClr val="tx1"/>
+              </a:solidFill>
+              <a:effectLst/>
+              <a:latin typeface="Arial" panose="020B0604020202020204" pitchFamily="34" charset="0"/>
+            </a:endParaRPr>
+          </a:p>
+          <a:p>
+            <a:pPr marL="285750" indent="-285750">
+              <a:lnSpc>
+                <a:spcPct val="150000"/>
+              </a:lnSpc>
+              <a:buFont typeface="Arial" panose="020B0604020202020204" pitchFamily="34" charset="0"/>
+              <a:buChar char="•"/>
+            </a:pPr>
+            <a:r>
+              <a:rPr lang="en-US" altLang="en-US" sz="1300" b="1">
+                <a:latin typeface="Arial" panose="020B0604020202020204" pitchFamily="34" charset="0"/>
+              </a:rPr>
+              <a:t>‘user.edit’ </a:t>
+            </a:r>
+            <a:r>
+              <a:rPr lang="az-Latn-AZ" altLang="en-US" sz="1300">
+                <a:latin typeface="Arial" panose="020B0604020202020204" pitchFamily="34" charset="0"/>
+              </a:rPr>
+              <a:t>parametri </a:t>
+            </a:r>
+            <a:r>
+              <a:rPr lang="en-US" altLang="en-US" sz="1300" b="1">
+                <a:latin typeface="Arial" panose="020B0604020202020204" pitchFamily="34" charset="0"/>
+              </a:rPr>
+              <a:t>web.php </a:t>
+            </a:r>
+            <a:r>
+              <a:rPr lang="az-Latn-AZ" altLang="en-US" sz="1300">
+                <a:latin typeface="Arial" panose="020B0604020202020204" pitchFamily="34" charset="0"/>
+              </a:rPr>
+              <a:t>faylında yazılan </a:t>
+            </a:r>
+            <a:r>
+              <a:rPr lang="az-Latn-AZ" altLang="en-US" sz="1300" b="1">
+                <a:latin typeface="Arial" panose="020B0604020202020204" pitchFamily="34" charset="0"/>
+              </a:rPr>
+              <a:t>'user/{id}/edit’ </a:t>
+            </a:r>
+            <a:r>
+              <a:rPr lang="az-Latn-AZ" altLang="en-US" sz="1300">
+                <a:latin typeface="Arial" panose="020B0604020202020204" pitchFamily="34" charset="0"/>
+              </a:rPr>
+              <a:t>routunu ifadə edir. </a:t>
+            </a:r>
+          </a:p>
+          <a:p>
+            <a:pPr marL="285750" indent="-285750">
+              <a:lnSpc>
+                <a:spcPct val="150000"/>
+              </a:lnSpc>
+              <a:buFont typeface="Arial" panose="020B0604020202020204" pitchFamily="34" charset="0"/>
+              <a:buChar char="•"/>
+            </a:pPr>
+            <a:r>
+              <a:rPr lang="az-Latn-AZ" altLang="en-US" sz="1300" b="1">
+                <a:latin typeface="Arial" panose="020B0604020202020204" pitchFamily="34" charset="0"/>
+              </a:rPr>
+              <a:t>$query-&gt;id </a:t>
+            </a:r>
+            <a:r>
+              <a:rPr lang="az-Latn-AZ" altLang="en-US" sz="1300">
+                <a:latin typeface="Arial" panose="020B0604020202020204" pitchFamily="34" charset="0"/>
+              </a:rPr>
+              <a:t>parametri isə həmin </a:t>
+            </a:r>
+            <a:r>
+              <a:rPr lang="az-Latn-AZ" altLang="en-US" sz="1300" b="1">
+                <a:latin typeface="Arial" panose="020B0604020202020204" pitchFamily="34" charset="0"/>
+              </a:rPr>
+              <a:t>route</a:t>
+            </a:r>
+            <a:r>
+              <a:rPr lang="az-Latn-AZ" altLang="en-US" sz="1300">
+                <a:latin typeface="Arial" panose="020B0604020202020204" pitchFamily="34" charset="0"/>
+              </a:rPr>
+              <a:t> -a </a:t>
+            </a:r>
+            <a:r>
+              <a:rPr lang="az-Latn-AZ" altLang="en-US" sz="1300" b="1">
+                <a:latin typeface="Arial" panose="020B0604020202020204" pitchFamily="34" charset="0"/>
+              </a:rPr>
+              <a:t>identifikator</a:t>
+            </a:r>
+            <a:r>
+              <a:rPr lang="az-Latn-AZ" altLang="en-US" sz="1300">
+                <a:latin typeface="Arial" panose="020B0604020202020204" pitchFamily="34" charset="0"/>
+              </a:rPr>
+              <a:t> (</a:t>
+            </a:r>
+            <a:r>
+              <a:rPr lang="az-Latn-AZ" altLang="en-US" sz="1300" b="1">
+                <a:latin typeface="Arial" panose="020B0604020202020204" pitchFamily="34" charset="0"/>
+              </a:rPr>
+              <a:t>id</a:t>
+            </a:r>
+            <a:r>
+              <a:rPr lang="az-Latn-AZ" altLang="en-US" sz="1300">
+                <a:latin typeface="Arial" panose="020B0604020202020204" pitchFamily="34" charset="0"/>
+              </a:rPr>
+              <a:t>) göndərir. </a:t>
+            </a:r>
+          </a:p>
+          <a:p>
+            <a:pPr>
+              <a:lnSpc>
+                <a:spcPct val="150000"/>
+              </a:lnSpc>
+              <a:buNone/>
+            </a:pPr>
+            <a:endParaRPr kumimoji="0" lang="az-Latn-AZ" altLang="en-US" sz="1300" b="0" i="0" u="none" strike="noStrike" cap="none" normalizeH="0" baseline="0">
+              <a:ln>
+                <a:noFill/>
+              </a:ln>
+              <a:solidFill>
+                <a:schemeClr val="tx1"/>
+              </a:solidFill>
+              <a:effectLst/>
+              <a:latin typeface="Arial" panose="020B0604020202020204" pitchFamily="34" charset="0"/>
+            </a:endParaRPr>
+          </a:p>
+          <a:p>
+            <a:pPr>
+              <a:lnSpc>
+                <a:spcPct val="150000"/>
+              </a:lnSpc>
+              <a:buNone/>
+            </a:pPr>
+            <a:r>
+              <a:rPr lang="az-Latn-AZ" altLang="en-US" sz="1300">
+                <a:latin typeface="Arial" panose="020B0604020202020204" pitchFamily="34" charset="0"/>
+              </a:rPr>
+              <a:t>Beləlikdə hər istifadəçi (</a:t>
+            </a:r>
+            <a:r>
+              <a:rPr lang="az-Latn-AZ" altLang="en-US" sz="1300" b="1">
+                <a:latin typeface="Arial" panose="020B0604020202020204" pitchFamily="34" charset="0"/>
+              </a:rPr>
+              <a:t>user</a:t>
+            </a:r>
+            <a:r>
+              <a:rPr lang="az-Latn-AZ" altLang="en-US" sz="1300">
+                <a:latin typeface="Arial" panose="020B0604020202020204" pitchFamily="34" charset="0"/>
+              </a:rPr>
+              <a:t>) üzərində </a:t>
+            </a:r>
+            <a:r>
+              <a:rPr lang="az-Latn-AZ" altLang="en-US" sz="1300" b="1">
+                <a:latin typeface="Arial" panose="020B0604020202020204" pitchFamily="34" charset="0"/>
+              </a:rPr>
+              <a:t>Edit</a:t>
+            </a:r>
+            <a:r>
+              <a:rPr lang="az-Latn-AZ" altLang="en-US" sz="1300">
+                <a:latin typeface="Arial" panose="020B0604020202020204" pitchFamily="34" charset="0"/>
+              </a:rPr>
+              <a:t> yaxud </a:t>
+            </a:r>
+            <a:r>
+              <a:rPr lang="az-Latn-AZ" altLang="en-US" sz="1300" b="1">
+                <a:latin typeface="Arial" panose="020B0604020202020204" pitchFamily="34" charset="0"/>
+              </a:rPr>
+              <a:t>Delete</a:t>
+            </a:r>
+            <a:r>
+              <a:rPr lang="az-Latn-AZ" altLang="en-US" sz="1300">
+                <a:latin typeface="Arial" panose="020B0604020202020204" pitchFamily="34" charset="0"/>
+              </a:rPr>
+              <a:t> kimi əməliyyatlar icra edə bilərik. İndilik sadəcə həmin istifadəçinin </a:t>
+            </a:r>
+            <a:r>
+              <a:rPr lang="az-Latn-AZ" altLang="en-US" sz="1300" b="1">
+                <a:latin typeface="Arial" panose="020B0604020202020204" pitchFamily="34" charset="0"/>
+              </a:rPr>
+              <a:t>İD</a:t>
+            </a:r>
+            <a:r>
+              <a:rPr lang="az-Latn-AZ" altLang="en-US" sz="1300">
+                <a:latin typeface="Arial" panose="020B0604020202020204" pitchFamily="34" charset="0"/>
+              </a:rPr>
+              <a:t> -sini </a:t>
+            </a:r>
+            <a:r>
+              <a:rPr lang="az-Latn-AZ" altLang="en-US" sz="1300" b="1">
+                <a:latin typeface="Arial" panose="020B0604020202020204" pitchFamily="34" charset="0"/>
+              </a:rPr>
+              <a:t>RETURN</a:t>
+            </a:r>
+            <a:r>
+              <a:rPr lang="az-Latn-AZ" altLang="en-US" sz="1300">
+                <a:latin typeface="Arial" panose="020B0604020202020204" pitchFamily="34" charset="0"/>
+              </a:rPr>
+              <a:t> edək və kodun işləyib işləmədiyini görək.</a:t>
+            </a:r>
+            <a:endParaRPr kumimoji="0" lang="az-Latn-AZ" altLang="en-US" sz="1300" b="0" i="0" u="none" strike="noStrike" cap="none" normalizeH="0" baseline="0">
+              <a:ln>
+                <a:noFill/>
+              </a:ln>
+              <a:solidFill>
+                <a:schemeClr val="tx1"/>
+              </a:solidFill>
+              <a:effectLst/>
+              <a:latin typeface="Arial" panose="020B0604020202020204" pitchFamily="34" charset="0"/>
+            </a:endParaRPr>
+          </a:p>
+          <a:p>
+            <a:pPr>
+              <a:lnSpc>
+                <a:spcPct val="150000"/>
+              </a:lnSpc>
+              <a:buNone/>
+            </a:pPr>
+            <a:endParaRPr kumimoji="0" lang="az-Latn-AZ" altLang="en-US" sz="1300" b="0" i="0" u="none" strike="noStrike" cap="none" normalizeH="0" baseline="0">
+              <a:ln>
+                <a:noFill/>
+              </a:ln>
+              <a:solidFill>
+                <a:schemeClr val="tx1"/>
+              </a:solidFill>
+              <a:effectLst/>
+              <a:latin typeface="Arial" panose="020B0604020202020204" pitchFamily="34" charset="0"/>
+            </a:endParaRPr>
+          </a:p>
+          <a:p>
+            <a:pPr>
+              <a:lnSpc>
+                <a:spcPct val="150000"/>
+              </a:lnSpc>
+              <a:buNone/>
+            </a:pPr>
+            <a:endParaRPr lang="az-Latn-AZ" altLang="en-US" sz="1300">
+              <a:latin typeface="Arial" panose="020B0604020202020204" pitchFamily="34" charset="0"/>
+            </a:endParaRPr>
+          </a:p>
+          <a:p>
+            <a:pPr>
+              <a:lnSpc>
+                <a:spcPct val="150000"/>
+              </a:lnSpc>
+              <a:buNone/>
+            </a:pPr>
+            <a:r>
+              <a:rPr kumimoji="0" lang="az-Latn-AZ" altLang="en-US" sz="1300" b="0" i="0" u="none" strike="noStrike" cap="none" normalizeH="0" baseline="0">
+                <a:ln>
+                  <a:noFill/>
+                </a:ln>
+                <a:solidFill>
+                  <a:schemeClr val="tx1"/>
+                </a:solidFill>
+                <a:effectLst/>
+                <a:latin typeface="Arial" panose="020B0604020202020204" pitchFamily="34" charset="0"/>
+              </a:rPr>
+              <a:t>Nəticə...</a:t>
+            </a:r>
+            <a:endParaRPr kumimoji="0" lang="en-US" altLang="en-US" sz="1300" b="0" i="0" u="none" strike="noStrike" cap="none" normalizeH="0" baseline="0">
+              <a:ln>
+                <a:noFill/>
+              </a:ln>
+              <a:solidFill>
+                <a:schemeClr val="tx1"/>
+              </a:solidFill>
+              <a:effectLst/>
+              <a:latin typeface="Arial" panose="020B0604020202020204" pitchFamily="34" charset="0"/>
+            </a:endParaRPr>
+          </a:p>
+        </p:txBody>
+      </p:sp>
+      <p:pic>
+        <p:nvPicPr>
+          <p:cNvPr id="4" name="Picture 3">
+            <a:extLst>
+              <a:ext uri="{FF2B5EF4-FFF2-40B4-BE49-F238E27FC236}">
+                <a16:creationId xmlns:a16="http://schemas.microsoft.com/office/drawing/2014/main" id="{EA507B00-E017-DA2E-7B42-EB997846843F}"/>
+              </a:ext>
+            </a:extLst>
+          </p:cNvPr>
+          <p:cNvPicPr>
+            <a:picLocks noChangeAspect="1"/>
+          </p:cNvPicPr>
+          <p:nvPr/>
+        </p:nvPicPr>
+        <p:blipFill>
+          <a:blip r:embed="rId2"/>
+          <a:stretch>
+            <a:fillRect/>
+          </a:stretch>
+        </p:blipFill>
+        <p:spPr>
+          <a:xfrm>
+            <a:off x="6096001" y="2590365"/>
+            <a:ext cx="6096000" cy="4267636"/>
+          </a:xfrm>
+          <a:prstGeom prst="rect">
+            <a:avLst/>
+          </a:prstGeom>
+        </p:spPr>
+      </p:pic>
+      <p:pic>
+        <p:nvPicPr>
+          <p:cNvPr id="6" name="Picture 5">
+            <a:extLst>
+              <a:ext uri="{FF2B5EF4-FFF2-40B4-BE49-F238E27FC236}">
+                <a16:creationId xmlns:a16="http://schemas.microsoft.com/office/drawing/2014/main" id="{129CE9D1-2EEA-5245-CA8D-1C665A8F056F}"/>
+              </a:ext>
+            </a:extLst>
+          </p:cNvPr>
+          <p:cNvPicPr>
+            <a:picLocks noChangeAspect="1"/>
+          </p:cNvPicPr>
+          <p:nvPr/>
+        </p:nvPicPr>
+        <p:blipFill>
+          <a:blip r:embed="rId3"/>
+          <a:stretch>
+            <a:fillRect/>
+          </a:stretch>
+        </p:blipFill>
+        <p:spPr>
+          <a:xfrm>
+            <a:off x="7156580" y="0"/>
+            <a:ext cx="5035420" cy="1234380"/>
+          </a:xfrm>
+          <a:prstGeom prst="rect">
+            <a:avLst/>
+          </a:prstGeom>
+          <a:ln w="38100" cap="sq">
+            <a:solidFill>
+              <a:srgbClr val="000000"/>
+            </a:solidFill>
+            <a:prstDash val="solid"/>
+            <a:miter lim="800000"/>
+          </a:ln>
+          <a:effectLst>
+            <a:outerShdw blurRad="50800" dist="38100" dir="2700000" algn="tl" rotWithShape="0">
+              <a:srgbClr val="000000">
+                <a:alpha val="43000"/>
+              </a:srgbClr>
+            </a:outerShdw>
+          </a:effectLst>
+        </p:spPr>
+      </p:pic>
+      <p:pic>
+        <p:nvPicPr>
+          <p:cNvPr id="8" name="Picture 7">
+            <a:extLst>
+              <a:ext uri="{FF2B5EF4-FFF2-40B4-BE49-F238E27FC236}">
+                <a16:creationId xmlns:a16="http://schemas.microsoft.com/office/drawing/2014/main" id="{C0347E39-D061-E088-55DF-DAB4241F7CB0}"/>
+              </a:ext>
+            </a:extLst>
+          </p:cNvPr>
+          <p:cNvPicPr>
+            <a:picLocks noChangeAspect="1"/>
+          </p:cNvPicPr>
+          <p:nvPr/>
+        </p:nvPicPr>
+        <p:blipFill>
+          <a:blip r:embed="rId4"/>
+          <a:stretch>
+            <a:fillRect/>
+          </a:stretch>
+        </p:blipFill>
+        <p:spPr>
+          <a:xfrm>
+            <a:off x="217714" y="3398409"/>
+            <a:ext cx="4801270" cy="1124107"/>
+          </a:xfrm>
+          <a:prstGeom prst="rect">
+            <a:avLst/>
+          </a:prstGeom>
+          <a:ln w="38100" cap="sq">
+            <a:solidFill>
+              <a:srgbClr val="000000"/>
+            </a:solidFill>
+            <a:prstDash val="solid"/>
+            <a:miter lim="800000"/>
+          </a:ln>
+          <a:effectLst>
+            <a:outerShdw blurRad="50800" dist="38100" dir="2700000" algn="tl" rotWithShape="0">
+              <a:srgbClr val="000000">
+                <a:alpha val="43000"/>
+              </a:srgbClr>
+            </a:outerShdw>
+          </a:effectLst>
+        </p:spPr>
+      </p:pic>
+    </p:spTree>
+    <p:extLst>
+      <p:ext uri="{BB962C8B-B14F-4D97-AF65-F5344CB8AC3E}">
+        <p14:creationId xmlns:p14="http://schemas.microsoft.com/office/powerpoint/2010/main" val="2667546121"/>
+      </p:ext>
+    </p:extLst>
+  </p:cSld>
+  <p:clrMapOvr>
+    <a:masterClrMapping/>
+  </p:clrMapOvr>
+</p:sld>
+</file>
+
+<file path=ppt/slides/slide5.xml><?xml version="1.0" encoding="utf-8"?>
+<p:sld xmlns:a="http://schemas.openxmlformats.org/drawingml/2006/main" xmlns:r="http://schemas.openxmlformats.org/officeDocument/2006/relationships" xmlns:p="http://schemas.openxmlformats.org/presentationml/2006/main">
+  <p:cSld>
+    <p:spTree>
+      <p:nvGrpSpPr>
+        <p:cNvPr id="1" name="">
+          <a:extLst>
+            <a:ext uri="{FF2B5EF4-FFF2-40B4-BE49-F238E27FC236}">
+              <a16:creationId xmlns:a16="http://schemas.microsoft.com/office/drawing/2014/main" id="{296B1D06-7CBD-C2C6-2BED-E10FB261F201}"/>
+            </a:ext>
+          </a:extLst>
+        </p:cNvPr>
+        <p:cNvGrpSpPr/>
+        <p:nvPr/>
+      </p:nvGrpSpPr>
+      <p:grpSpPr>
+        <a:xfrm>
+          <a:off x="0" y="0"/>
+          <a:ext cx="0" cy="0"/>
+          <a:chOff x="0" y="0"/>
+          <a:chExt cx="0" cy="0"/>
+        </a:xfrm>
+      </p:grpSpPr>
+      <p:sp>
+        <p:nvSpPr>
+          <p:cNvPr id="3" name="TextBox 2">
+            <a:extLst>
+              <a:ext uri="{FF2B5EF4-FFF2-40B4-BE49-F238E27FC236}">
+                <a16:creationId xmlns:a16="http://schemas.microsoft.com/office/drawing/2014/main" id="{210A88DD-6B6D-97D5-467D-D9A317EE0AC9}"/>
+              </a:ext>
+            </a:extLst>
+          </p:cNvPr>
+          <p:cNvSpPr txBox="1"/>
+          <p:nvPr/>
+        </p:nvSpPr>
+        <p:spPr>
+          <a:xfrm>
+            <a:off x="217715" y="255046"/>
+            <a:ext cx="5641910" cy="2455929"/>
+          </a:xfrm>
+          <a:prstGeom prst="rect">
+            <a:avLst/>
+          </a:prstGeom>
+          <a:noFill/>
+        </p:spPr>
+        <p:txBody>
+          <a:bodyPr wrap="square">
+            <a:spAutoFit/>
+          </a:bodyPr>
+          <a:lstStyle/>
+          <a:p>
+            <a:pPr>
+              <a:lnSpc>
+                <a:spcPct val="150000"/>
+              </a:lnSpc>
+              <a:buNone/>
+            </a:pPr>
+            <a:r>
+              <a:rPr lang="az-Latn-AZ" altLang="en-US" sz="1300">
+                <a:latin typeface="Arial" panose="020B0604020202020204" pitchFamily="34" charset="0"/>
+              </a:rPr>
+              <a:t>Həmin </a:t>
+            </a:r>
+            <a:r>
+              <a:rPr lang="az-Latn-AZ" altLang="en-US" sz="1300" b="1">
+                <a:latin typeface="Arial" panose="020B0604020202020204" pitchFamily="34" charset="0"/>
+              </a:rPr>
+              <a:t>CALLBACK</a:t>
+            </a:r>
+            <a:r>
+              <a:rPr lang="az-Latn-AZ" altLang="en-US" sz="1300">
+                <a:latin typeface="Arial" panose="020B0604020202020204" pitchFamily="34" charset="0"/>
+              </a:rPr>
+              <a:t> ilə sadə formada əlavə etdiyimiz kimi sadə mətndə əlavə edə bilirik.</a:t>
+            </a:r>
+          </a:p>
+          <a:p>
+            <a:pPr>
+              <a:lnSpc>
+                <a:spcPct val="150000"/>
+              </a:lnSpc>
+              <a:buNone/>
+            </a:pPr>
+            <a:endParaRPr lang="en-US" altLang="en-US" sz="1300">
+              <a:latin typeface="Arial" panose="020B0604020202020204" pitchFamily="34" charset="0"/>
+            </a:endParaRPr>
+          </a:p>
+          <a:p>
+            <a:pPr>
+              <a:lnSpc>
+                <a:spcPct val="150000"/>
+              </a:lnSpc>
+              <a:buNone/>
+            </a:pPr>
+            <a:r>
+              <a:rPr kumimoji="0" lang="en-US" altLang="en-US" sz="1300" b="0" i="0" u="none" strike="noStrike" cap="none" normalizeH="0" baseline="0">
+                <a:ln>
+                  <a:noFill/>
+                </a:ln>
+                <a:solidFill>
+                  <a:schemeClr val="tx1"/>
+                </a:solidFill>
+                <a:effectLst/>
+                <a:latin typeface="Arial" panose="020B0604020202020204" pitchFamily="34" charset="0"/>
+              </a:rPr>
+              <a:t>Sad</a:t>
+            </a:r>
+            <a:r>
+              <a:rPr kumimoji="0" lang="az-Latn-AZ" altLang="en-US" sz="1300" b="0" i="0" u="none" strike="noStrike" cap="none" normalizeH="0" baseline="0">
+                <a:ln>
+                  <a:noFill/>
+                </a:ln>
+                <a:solidFill>
+                  <a:schemeClr val="tx1"/>
+                </a:solidFill>
+                <a:effectLst/>
+                <a:latin typeface="Arial" panose="020B0604020202020204" pitchFamily="34" charset="0"/>
+              </a:rPr>
+              <a:t>ə forma belə idi.</a:t>
+            </a:r>
+          </a:p>
+          <a:p>
+            <a:pPr>
+              <a:lnSpc>
+                <a:spcPct val="150000"/>
+              </a:lnSpc>
+              <a:buNone/>
+            </a:pPr>
+            <a:endParaRPr lang="az-Latn-AZ" altLang="en-US" sz="1300">
+              <a:latin typeface="Arial" panose="020B0604020202020204" pitchFamily="34" charset="0"/>
+            </a:endParaRPr>
+          </a:p>
+          <a:p>
+            <a:pPr>
+              <a:lnSpc>
+                <a:spcPct val="150000"/>
+              </a:lnSpc>
+              <a:buNone/>
+            </a:pPr>
+            <a:endParaRPr kumimoji="0" lang="az-Latn-AZ" altLang="en-US" sz="1300" b="0" i="0" u="none" strike="noStrike" cap="none" normalizeH="0" baseline="0">
+              <a:ln>
+                <a:noFill/>
+              </a:ln>
+              <a:solidFill>
+                <a:schemeClr val="tx1"/>
+              </a:solidFill>
+              <a:effectLst/>
+              <a:latin typeface="Arial" panose="020B0604020202020204" pitchFamily="34" charset="0"/>
+            </a:endParaRPr>
+          </a:p>
+          <a:p>
+            <a:pPr>
+              <a:lnSpc>
+                <a:spcPct val="150000"/>
+              </a:lnSpc>
+              <a:buNone/>
+            </a:pPr>
+            <a:endParaRPr lang="az-Latn-AZ" altLang="en-US" sz="1300">
+              <a:latin typeface="Arial" panose="020B0604020202020204" pitchFamily="34" charset="0"/>
+            </a:endParaRPr>
+          </a:p>
+          <a:p>
+            <a:pPr>
+              <a:lnSpc>
+                <a:spcPct val="150000"/>
+              </a:lnSpc>
+              <a:buNone/>
+            </a:pPr>
+            <a:r>
+              <a:rPr kumimoji="0" lang="az-Latn-AZ" altLang="en-US" sz="1300" b="0" i="0" u="none" strike="noStrike" cap="none" normalizeH="0" baseline="0">
+                <a:ln>
+                  <a:noFill/>
+                </a:ln>
+                <a:solidFill>
+                  <a:schemeClr val="tx1"/>
+                </a:solidFill>
+                <a:effectLst/>
+                <a:latin typeface="Arial" panose="020B0604020202020204" pitchFamily="34" charset="0"/>
+              </a:rPr>
+              <a:t>Nəticə...</a:t>
+            </a:r>
+            <a:endParaRPr kumimoji="0" lang="en-US" altLang="en-US" sz="1300" b="0" i="0" u="none" strike="noStrike" cap="none" normalizeH="0" baseline="0">
+              <a:ln>
+                <a:noFill/>
+              </a:ln>
+              <a:solidFill>
+                <a:schemeClr val="tx1"/>
+              </a:solidFill>
+              <a:effectLst/>
+              <a:latin typeface="Arial" panose="020B0604020202020204" pitchFamily="34" charset="0"/>
+            </a:endParaRPr>
+          </a:p>
+        </p:txBody>
+      </p:sp>
+      <p:pic>
+        <p:nvPicPr>
+          <p:cNvPr id="4" name="Picture 3">
+            <a:extLst>
+              <a:ext uri="{FF2B5EF4-FFF2-40B4-BE49-F238E27FC236}">
+                <a16:creationId xmlns:a16="http://schemas.microsoft.com/office/drawing/2014/main" id="{2EA0A557-C47B-4CFF-89DA-47BD9B6347BA}"/>
+              </a:ext>
+            </a:extLst>
+          </p:cNvPr>
+          <p:cNvPicPr>
+            <a:picLocks noChangeAspect="1"/>
+          </p:cNvPicPr>
+          <p:nvPr/>
+        </p:nvPicPr>
+        <p:blipFill>
+          <a:blip r:embed="rId2"/>
+          <a:stretch>
+            <a:fillRect/>
+          </a:stretch>
+        </p:blipFill>
+        <p:spPr>
+          <a:xfrm>
+            <a:off x="6068786" y="0"/>
+            <a:ext cx="6123214" cy="6858000"/>
+          </a:xfrm>
+          <a:prstGeom prst="rect">
+            <a:avLst/>
+          </a:prstGeom>
+        </p:spPr>
+      </p:pic>
+      <p:pic>
+        <p:nvPicPr>
+          <p:cNvPr id="6" name="Picture 5">
+            <a:extLst>
+              <a:ext uri="{FF2B5EF4-FFF2-40B4-BE49-F238E27FC236}">
+                <a16:creationId xmlns:a16="http://schemas.microsoft.com/office/drawing/2014/main" id="{AAC552A4-0F1F-77A4-DCAA-564EDE8E23AE}"/>
+              </a:ext>
+            </a:extLst>
+          </p:cNvPr>
+          <p:cNvPicPr>
+            <a:picLocks noChangeAspect="1"/>
+          </p:cNvPicPr>
+          <p:nvPr/>
+        </p:nvPicPr>
+        <p:blipFill>
+          <a:blip r:embed="rId3"/>
+          <a:stretch>
+            <a:fillRect/>
+          </a:stretch>
+        </p:blipFill>
+        <p:spPr>
+          <a:xfrm>
+            <a:off x="217715" y="1510646"/>
+            <a:ext cx="2219635" cy="362001"/>
+          </a:xfrm>
+          <a:prstGeom prst="rect">
+            <a:avLst/>
+          </a:prstGeom>
+        </p:spPr>
+      </p:pic>
+      <p:pic>
+        <p:nvPicPr>
+          <p:cNvPr id="8" name="Picture 7">
+            <a:extLst>
+              <a:ext uri="{FF2B5EF4-FFF2-40B4-BE49-F238E27FC236}">
+                <a16:creationId xmlns:a16="http://schemas.microsoft.com/office/drawing/2014/main" id="{408EDDAE-9285-AF28-2370-F7A6BF008904}"/>
+              </a:ext>
+            </a:extLst>
+          </p:cNvPr>
+          <p:cNvPicPr>
+            <a:picLocks noChangeAspect="1"/>
+          </p:cNvPicPr>
+          <p:nvPr/>
+        </p:nvPicPr>
+        <p:blipFill>
+          <a:blip r:embed="rId4"/>
+          <a:stretch>
+            <a:fillRect/>
+          </a:stretch>
+        </p:blipFill>
+        <p:spPr>
+          <a:xfrm>
+            <a:off x="217715" y="2752964"/>
+            <a:ext cx="4641090" cy="977654"/>
+          </a:xfrm>
+          <a:prstGeom prst="rect">
+            <a:avLst/>
+          </a:prstGeom>
+          <a:ln w="38100" cap="sq">
+            <a:solidFill>
+              <a:srgbClr val="000000"/>
+            </a:solidFill>
+            <a:prstDash val="solid"/>
+            <a:miter lim="800000"/>
+          </a:ln>
+          <a:effectLst>
+            <a:outerShdw blurRad="50800" dist="38100" dir="2700000" algn="tl" rotWithShape="0">
+              <a:srgbClr val="000000">
+                <a:alpha val="43000"/>
+              </a:srgbClr>
+            </a:outerShdw>
+          </a:effectLst>
+        </p:spPr>
+      </p:pic>
+    </p:spTree>
+    <p:extLst>
+      <p:ext uri="{BB962C8B-B14F-4D97-AF65-F5344CB8AC3E}">
+        <p14:creationId xmlns:p14="http://schemas.microsoft.com/office/powerpoint/2010/main" val="353322280"/>
+      </p:ext>
+    </p:extLst>
+  </p:cSld>
+  <p:clrMapOvr>
+    <a:masterClrMapping/>
+  </p:clrMapOvr>
+</p:sld>
+</file>
+
+<file path=ppt/slides/slide6.xml><?xml version="1.0" encoding="utf-8"?>
+<p:sld xmlns:a="http://schemas.openxmlformats.org/drawingml/2006/main" xmlns:r="http://schemas.openxmlformats.org/officeDocument/2006/relationships" xmlns:p="http://schemas.openxmlformats.org/presentationml/2006/main">
+  <p:cSld>
+    <p:spTree>
+      <p:nvGrpSpPr>
+        <p:cNvPr id="1" name="">
+          <a:extLst>
+            <a:ext uri="{FF2B5EF4-FFF2-40B4-BE49-F238E27FC236}">
+              <a16:creationId xmlns:a16="http://schemas.microsoft.com/office/drawing/2014/main" id="{33B75773-8E18-8207-FB8C-7C049287B90F}"/>
+            </a:ext>
+          </a:extLst>
+        </p:cNvPr>
+        <p:cNvGrpSpPr/>
+        <p:nvPr/>
+      </p:nvGrpSpPr>
+      <p:grpSpPr>
+        <a:xfrm>
+          <a:off x="0" y="0"/>
+          <a:ext cx="0" cy="0"/>
+          <a:chOff x="0" y="0"/>
+          <a:chExt cx="0" cy="0"/>
+        </a:xfrm>
+      </p:grpSpPr>
+      <p:sp>
+        <p:nvSpPr>
+          <p:cNvPr id="3" name="TextBox 2">
+            <a:extLst>
+              <a:ext uri="{FF2B5EF4-FFF2-40B4-BE49-F238E27FC236}">
+                <a16:creationId xmlns:a16="http://schemas.microsoft.com/office/drawing/2014/main" id="{CBF57F4B-14BE-2377-927A-5892EC9BD13B}"/>
+              </a:ext>
+            </a:extLst>
+          </p:cNvPr>
+          <p:cNvSpPr txBox="1"/>
+          <p:nvPr/>
+        </p:nvSpPr>
+        <p:spPr>
+          <a:xfrm>
+            <a:off x="217714" y="255046"/>
+            <a:ext cx="11756571" cy="355354"/>
+          </a:xfrm>
+          <a:prstGeom prst="rect">
+            <a:avLst/>
+          </a:prstGeom>
+          <a:noFill/>
+        </p:spPr>
+        <p:txBody>
+          <a:bodyPr wrap="square">
+            <a:spAutoFit/>
+          </a:bodyPr>
+          <a:lstStyle/>
+          <a:p>
+            <a:pPr>
+              <a:lnSpc>
+                <a:spcPct val="150000"/>
+              </a:lnSpc>
+              <a:buNone/>
+            </a:pPr>
+            <a:r>
+              <a:rPr kumimoji="0" lang="en-US" altLang="en-US" sz="1300" b="0" i="0" u="none" strike="noStrike" cap="none" normalizeH="0" baseline="0">
+                <a:ln>
+                  <a:noFill/>
+                </a:ln>
+                <a:solidFill>
+                  <a:schemeClr val="tx1"/>
+                </a:solidFill>
+                <a:effectLst/>
+                <a:latin typeface="Arial" panose="020B0604020202020204" pitchFamily="34" charset="0"/>
+              </a:rPr>
+              <a:t>.</a:t>
+            </a:r>
+          </a:p>
+        </p:txBody>
+      </p:sp>
+    </p:spTree>
+    <p:extLst>
+      <p:ext uri="{BB962C8B-B14F-4D97-AF65-F5344CB8AC3E}">
+        <p14:creationId xmlns:p14="http://schemas.microsoft.com/office/powerpoint/2010/main" val="2445154006"/>
+      </p:ext>
+    </p:extLst>
+  </p:cSld>
+  <p:clrMapOvr>
+    <a:masterClrMapping/>
+  </p:clrMapOvr>
+</p:sld>
+</file>
+
+<file path=ppt/slides/slide7.xml><?xml version="1.0" encoding="utf-8"?>
+<p:sld xmlns:a="http://schemas.openxmlformats.org/drawingml/2006/main" xmlns:r="http://schemas.openxmlformats.org/officeDocument/2006/relationships" xmlns:p="http://schemas.openxmlformats.org/presentationml/2006/main">
+  <p:cSld>
+    <p:spTree>
+      <p:nvGrpSpPr>
+        <p:cNvPr id="1" name="">
+          <a:extLst>
+            <a:ext uri="{FF2B5EF4-FFF2-40B4-BE49-F238E27FC236}">
+              <a16:creationId xmlns:a16="http://schemas.microsoft.com/office/drawing/2014/main" id="{C84532D7-F5C1-5524-3C16-0FFEC6BD31A7}"/>
+            </a:ext>
+          </a:extLst>
+        </p:cNvPr>
+        <p:cNvGrpSpPr/>
+        <p:nvPr/>
+      </p:nvGrpSpPr>
+      <p:grpSpPr>
+        <a:xfrm>
+          <a:off x="0" y="0"/>
+          <a:ext cx="0" cy="0"/>
+          <a:chOff x="0" y="0"/>
+          <a:chExt cx="0" cy="0"/>
+        </a:xfrm>
+      </p:grpSpPr>
+      <p:sp>
+        <p:nvSpPr>
+          <p:cNvPr id="3" name="TextBox 2">
+            <a:extLst>
+              <a:ext uri="{FF2B5EF4-FFF2-40B4-BE49-F238E27FC236}">
+                <a16:creationId xmlns:a16="http://schemas.microsoft.com/office/drawing/2014/main" id="{EA260704-F0AB-3C1B-9B3B-8C3EB4776717}"/>
+              </a:ext>
+            </a:extLst>
+          </p:cNvPr>
+          <p:cNvSpPr txBox="1"/>
+          <p:nvPr/>
+        </p:nvSpPr>
+        <p:spPr>
+          <a:xfrm>
+            <a:off x="217714" y="255046"/>
+            <a:ext cx="11756571" cy="355354"/>
+          </a:xfrm>
+          <a:prstGeom prst="rect">
+            <a:avLst/>
+          </a:prstGeom>
+          <a:noFill/>
+        </p:spPr>
+        <p:txBody>
+          <a:bodyPr wrap="square">
+            <a:spAutoFit/>
+          </a:bodyPr>
+          <a:lstStyle/>
+          <a:p>
+            <a:pPr>
+              <a:lnSpc>
+                <a:spcPct val="150000"/>
+              </a:lnSpc>
+              <a:buNone/>
+            </a:pPr>
+            <a:r>
+              <a:rPr kumimoji="0" lang="en-US" altLang="en-US" sz="1300" b="0" i="0" u="none" strike="noStrike" cap="none" normalizeH="0" baseline="0">
+                <a:ln>
+                  <a:noFill/>
+                </a:ln>
+                <a:solidFill>
+                  <a:schemeClr val="tx1"/>
+                </a:solidFill>
+                <a:effectLst/>
+                <a:latin typeface="Arial" panose="020B0604020202020204" pitchFamily="34" charset="0"/>
+              </a:rPr>
+              <a:t>.</a:t>
+            </a:r>
+          </a:p>
+        </p:txBody>
+      </p:sp>
+    </p:spTree>
+    <p:extLst>
+      <p:ext uri="{BB962C8B-B14F-4D97-AF65-F5344CB8AC3E}">
+        <p14:creationId xmlns:p14="http://schemas.microsoft.com/office/powerpoint/2010/main" val="1967960365"/>
+      </p:ext>
+    </p:extLst>
+  </p:cSld>
+  <p:clrMapOvr>
+    <a:masterClrMapping/>
+  </p:clrMapOvr>
+</p:sld>
+</file>
+
+<file path=ppt/slides/slide8.xml><?xml version="1.0" encoding="utf-8"?>
+<p:sld xmlns:a="http://schemas.openxmlformats.org/drawingml/2006/main" xmlns:r="http://schemas.openxmlformats.org/officeDocument/2006/relationships" xmlns:p="http://schemas.openxmlformats.org/presentationml/2006/main">
+  <p:cSld>
+    <p:spTree>
+      <p:nvGrpSpPr>
+        <p:cNvPr id="1" name="">
+          <a:extLst>
+            <a:ext uri="{FF2B5EF4-FFF2-40B4-BE49-F238E27FC236}">
+              <a16:creationId xmlns:a16="http://schemas.microsoft.com/office/drawing/2014/main" id="{038AD562-AE86-8464-91E6-93CF5EDDB8FC}"/>
+            </a:ext>
+          </a:extLst>
+        </p:cNvPr>
+        <p:cNvGrpSpPr/>
+        <p:nvPr/>
+      </p:nvGrpSpPr>
+      <p:grpSpPr>
+        <a:xfrm>
+          <a:off x="0" y="0"/>
+          <a:ext cx="0" cy="0"/>
+          <a:chOff x="0" y="0"/>
+          <a:chExt cx="0" cy="0"/>
+        </a:xfrm>
+      </p:grpSpPr>
+      <p:sp>
+        <p:nvSpPr>
+          <p:cNvPr id="3" name="TextBox 2">
+            <a:extLst>
+              <a:ext uri="{FF2B5EF4-FFF2-40B4-BE49-F238E27FC236}">
+                <a16:creationId xmlns:a16="http://schemas.microsoft.com/office/drawing/2014/main" id="{340EAEAF-B64A-4DA3-C076-9472A9F9F85E}"/>
+              </a:ext>
+            </a:extLst>
+          </p:cNvPr>
+          <p:cNvSpPr txBox="1"/>
+          <p:nvPr/>
+        </p:nvSpPr>
+        <p:spPr>
+          <a:xfrm>
+            <a:off x="217714" y="255046"/>
+            <a:ext cx="11756571" cy="355354"/>
+          </a:xfrm>
+          <a:prstGeom prst="rect">
+            <a:avLst/>
+          </a:prstGeom>
+          <a:noFill/>
+        </p:spPr>
+        <p:txBody>
+          <a:bodyPr wrap="square">
+            <a:spAutoFit/>
+          </a:bodyPr>
+          <a:lstStyle/>
+          <a:p>
+            <a:pPr>
+              <a:lnSpc>
+                <a:spcPct val="150000"/>
+              </a:lnSpc>
+              <a:buNone/>
+            </a:pPr>
+            <a:r>
+              <a:rPr kumimoji="0" lang="en-US" altLang="en-US" sz="1300" b="0" i="0" u="none" strike="noStrike" cap="none" normalizeH="0" baseline="0">
+                <a:ln>
+                  <a:noFill/>
+                </a:ln>
+                <a:solidFill>
+                  <a:schemeClr val="tx1"/>
+                </a:solidFill>
+                <a:effectLst/>
+                <a:latin typeface="Arial" panose="020B0604020202020204" pitchFamily="34" charset="0"/>
+              </a:rPr>
+              <a:t>.</a:t>
+            </a:r>
+          </a:p>
+        </p:txBody>
+      </p:sp>
+    </p:spTree>
+    <p:extLst>
+      <p:ext uri="{BB962C8B-B14F-4D97-AF65-F5344CB8AC3E}">
+        <p14:creationId xmlns:p14="http://schemas.microsoft.com/office/powerpoint/2010/main" val="820306072"/>
+      </p:ext>
+    </p:extLst>
+  </p:cSld>
+  <p:clrMapOvr>
+    <a:masterClrMapping/>
+  </p:clrMapOvr>
+</p:sld>
+</file>
+
+<file path=ppt/slides/slide9.xml><?xml version="1.0" encoding="utf-8"?>
 <p:sld xmlns:a="http://schemas.openxmlformats.org/drawingml/2006/main" xmlns:r="http://schemas.openxmlformats.org/officeDocument/2006/relationships" xmlns:p="http://schemas.openxmlformats.org/presentationml/2006/main">
   <p:cSld>
     <p:spTree>

</xml_diff>